<commit_message>
Poster: UNSW header from the template master, as in the example poster
The title layout stretched a second banner image from 4.2:1 to 5.4:1; it is
removed so the master banner shows, and the title block moves up to match.

Co-Authored-By: Claude Opus 5.5 <noreply@anthropic.com>
Claude-Session: https://claude.ai/code/session_01PTFeJVKomSrXvcoBdZ7d4L
</commit_message>
<xml_diff>
--- a/ThesisA/poster/Thesis_Poster_A0.pptx
+++ b/ThesisA/poster/Thesis_Poster_A0.pptx
@@ -588,36 +588,6 @@
           <a:chExt cx="0" cy="0"/>
         </a:xfrm>
       </p:grpSpPr>
-      <p:pic>
-        <p:nvPicPr>
-          <p:cNvPr id="4" name="Picture 3"/>
-          <p:cNvPicPr>
-            <a:picLocks noChangeAspect="1"/>
-          </p:cNvPicPr>
-          <p:nvPr userDrawn="1"/>
-        </p:nvPicPr>
-        <p:blipFill>
-          <a:blip r:embed="rId2">
-            <a:extLst>
-              <a:ext uri="{28A0092B-C50C-407E-A947-70E740481C1C}">
-                <a14:useLocalDpi xmlns:a14="http://schemas.microsoft.com/office/drawing/2010/main" val="0"/>
-              </a:ext>
-            </a:extLst>
-          </a:blip>
-          <a:stretch>
-            <a:fillRect/>
-          </a:stretch>
-        </p:blipFill>
-        <p:spPr>
-          <a:xfrm>
-            <a:off x="-1" y="0"/>
-            <a:ext cx="30275213" cy="5582653"/>
-          </a:xfrm>
-          <a:prstGeom prst="rect">
-            <a:avLst/>
-          </a:prstGeom>
-        </p:spPr>
-      </p:pic>
     </p:spTree>
     <p:extLst>
       <p:ext uri="{BB962C8B-B14F-4D97-AF65-F5344CB8AC3E}">
@@ -10550,50 +10520,6 @@
           </a:prstGeom>
         </p:spPr>
       </p:pic>
-      <p:sp>
-        <p:nvSpPr>
-          <p:cNvPr id="3" name="TextBox 2"/>
-          <p:cNvSpPr txBox="1"/>
-          <p:nvPr userDrawn="1"/>
-        </p:nvSpPr>
-        <p:spPr>
-          <a:xfrm>
-            <a:off x="10491549" y="862280"/>
-            <a:ext cx="9288371" cy="1200329"/>
-          </a:xfrm>
-          <a:prstGeom prst="rect">
-            <a:avLst/>
-          </a:prstGeom>
-          <a:noFill/>
-        </p:spPr>
-        <p:txBody>
-          <a:bodyPr wrap="square" numCol="1" rtlCol="0">
-            <a:spAutoFit/>
-          </a:bodyPr>
-          <a:lstStyle/>
-          <a:p>
-            <a:pPr marL="0" indent="0" algn="l"/>
-            <a:r>
-              <a:rPr lang="en-AU" sz="7200" b="0" dirty="0" smtClean="0">
-                <a:latin typeface="Arial" pitchFamily="34" charset="0"/>
-                <a:cs typeface="Arial" pitchFamily="34" charset="0"/>
-              </a:rPr>
-              <a:t>BE Thesis </a:t>
-            </a:r>
-            <a:r>
-              <a:rPr lang="en-AU" sz="7200" b="0" smtClean="0">
-                <a:latin typeface="Arial" pitchFamily="34" charset="0"/>
-                <a:cs typeface="Arial" pitchFamily="34" charset="0"/>
-              </a:rPr>
-              <a:t>– S2/2016</a:t>
-            </a:r>
-            <a:endParaRPr lang="en-AU" sz="7200" b="0" dirty="0" smtClean="0">
-              <a:latin typeface="Arial" pitchFamily="34" charset="0"/>
-              <a:cs typeface="Arial" pitchFamily="34" charset="0"/>
-            </a:endParaRPr>
-          </a:p>
-        </p:txBody>
-      </p:sp>
     </p:spTree>
     <p:extLst>
       <p:ext uri="{BB962C8B-B14F-4D97-AF65-F5344CB8AC3E}">
@@ -12414,7 +12340,7 @@
         </p:nvSpPr>
         <p:spPr>
           <a:xfrm>
-            <a:off x="216000" y="5734309"/>
+            <a:off x="216000" y="4069080"/>
             <a:ext cx="29843999" cy="3200876"/>
           </a:xfrm>
           <a:prstGeom prst="rect">
@@ -12467,8 +12393,8 @@
         </p:nvSpPr>
         <p:spPr>
           <a:xfrm>
-            <a:off x="10754019" y="1816752"/>
-            <a:ext cx="10132802" cy="1169551"/>
+            <a:off x="10491549" y="862280"/>
+            <a:ext cx="13500000" cy="1169551"/>
           </a:xfrm>
           <a:prstGeom prst="rect">
             <a:avLst/>
@@ -12482,14 +12408,14 @@
           <a:lstStyle/>
           <a:p>
             <a:r>
-              <a:rPr lang="en-AU" sz="7000" b="1" dirty="0" smtClean="0">
+              <a:rPr lang="en-AU" sz="7200" b="0" dirty="0" smtClean="0">
                 <a:latin typeface="Arial" pitchFamily="34" charset="0"/>
                 <a:cs typeface="Arial" pitchFamily="34" charset="0"/>
               </a:rPr>
-              <a:t>Thesis 2026</a:t>
-            </a:r>
-            <a:r>
-              <a:rPr lang="en-AU" sz="7000" b="1" dirty="0" smtClean="0">
+              <a:t>2026 Thesis Project</a:t>
+            </a:r>
+            <a:r>
+              <a:rPr lang="en-AU" sz="7200" b="0" dirty="0" smtClean="0">
                 <a:latin typeface="Arial" pitchFamily="34" charset="0"/>
                 <a:cs typeface="Arial" pitchFamily="34" charset="0"/>
               </a:rPr>
@@ -12510,8 +12436,8 @@
         </p:nvSpPr>
         <p:spPr>
           <a:xfrm>
-            <a:off x="777240" y="10378440"/>
-            <a:ext cx="11521440" cy="5943600"/>
+            <a:off x="777240" y="8714232"/>
+            <a:ext cx="11521440" cy="6035040"/>
           </a:xfrm>
           <a:prstGeom prst="roundRect">
             <a:avLst>
@@ -12554,7 +12480,7 @@
         </p:nvSpPr>
         <p:spPr>
           <a:xfrm>
-            <a:off x="1097280" y="10607040"/>
+            <a:off x="1097280" y="8942832"/>
             <a:ext cx="10881360" cy="640080"/>
           </a:xfrm>
           <a:prstGeom prst="rect">
@@ -12593,7 +12519,7 @@
         </p:nvSpPr>
         <p:spPr>
           <a:xfrm>
-            <a:off x="1097280" y="11338560"/>
+            <a:off x="1097280" y="9674352"/>
             <a:ext cx="10881360" cy="2377440"/>
           </a:xfrm>
           <a:prstGeom prst="rect">
@@ -12739,7 +12665,7 @@
         </p:nvSpPr>
         <p:spPr>
           <a:xfrm>
-            <a:off x="1097280" y="13990320"/>
+            <a:off x="1097280" y="12326112"/>
             <a:ext cx="2331720" cy="1691640"/>
           </a:xfrm>
           <a:prstGeom prst="roundRect">
@@ -12816,7 +12742,7 @@
         </p:nvSpPr>
         <p:spPr>
           <a:xfrm>
-            <a:off x="4480560" y="13990320"/>
+            <a:off x="4480560" y="12326112"/>
             <a:ext cx="2331720" cy="1691640"/>
           </a:xfrm>
           <a:prstGeom prst="roundRect">
@@ -12893,7 +12819,7 @@
         </p:nvSpPr>
         <p:spPr>
           <a:xfrm>
-            <a:off x="7863840" y="13990320"/>
+            <a:off x="7863840" y="12326112"/>
             <a:ext cx="2331720" cy="1691640"/>
           </a:xfrm>
           <a:prstGeom prst="roundRect">
@@ -12970,7 +12896,7 @@
         </p:nvSpPr>
         <p:spPr>
           <a:xfrm>
-            <a:off x="3520440" y="14424660"/>
+            <a:off x="3520440" y="12760452"/>
             <a:ext cx="868680" cy="822960"/>
           </a:xfrm>
           <a:prstGeom prst="rightArrow">
@@ -13014,7 +12940,7 @@
         </p:nvSpPr>
         <p:spPr>
           <a:xfrm>
-            <a:off x="6903720" y="14717268"/>
+            <a:off x="6903720" y="13053060"/>
             <a:ext cx="868680" cy="237744"/>
           </a:xfrm>
           <a:prstGeom prst="rightArrow">
@@ -13058,7 +12984,7 @@
         </p:nvSpPr>
         <p:spPr>
           <a:xfrm>
-            <a:off x="6560820" y="15019020"/>
+            <a:off x="6560820" y="13354812"/>
             <a:ext cx="1554480" cy="548640"/>
           </a:xfrm>
           <a:prstGeom prst="rect">
@@ -13097,7 +13023,7 @@
         </p:nvSpPr>
         <p:spPr>
           <a:xfrm>
-            <a:off x="7680960" y="15727680"/>
+            <a:off x="7680960" y="14063472"/>
             <a:ext cx="2697479" cy="457200"/>
           </a:xfrm>
           <a:prstGeom prst="rect">
@@ -13136,8 +13062,8 @@
         </p:nvSpPr>
         <p:spPr>
           <a:xfrm>
-            <a:off x="12710159" y="10378440"/>
-            <a:ext cx="10067543" cy="5943600"/>
+            <a:off x="12710159" y="8714232"/>
+            <a:ext cx="10067543" cy="6035040"/>
           </a:xfrm>
           <a:prstGeom prst="roundRect">
             <a:avLst>
@@ -13180,7 +13106,7 @@
         </p:nvSpPr>
         <p:spPr>
           <a:xfrm>
-            <a:off x="13030199" y="10607040"/>
+            <a:off x="13030199" y="8942832"/>
             <a:ext cx="9427463" cy="640080"/>
           </a:xfrm>
           <a:prstGeom prst="rect">
@@ -13219,8 +13145,8 @@
         </p:nvSpPr>
         <p:spPr>
           <a:xfrm>
-            <a:off x="13030199" y="11338560"/>
-            <a:ext cx="9427463" cy="4846320"/>
+            <a:off x="13030199" y="9674352"/>
+            <a:ext cx="9427463" cy="4937759"/>
           </a:xfrm>
           <a:prstGeom prst="rect">
             <a:avLst/>
@@ -13427,8 +13353,8 @@
         </p:nvSpPr>
         <p:spPr>
           <a:xfrm>
-            <a:off x="23189183" y="10378440"/>
-            <a:ext cx="6309360" cy="5943600"/>
+            <a:off x="23189183" y="8714232"/>
+            <a:ext cx="6309360" cy="6035040"/>
           </a:xfrm>
           <a:prstGeom prst="roundRect">
             <a:avLst>
@@ -13489,8 +13415,8 @@
         </p:nvSpPr>
         <p:spPr>
           <a:xfrm>
-            <a:off x="777240" y="16779240"/>
-            <a:ext cx="28721303" cy="20802600"/>
+            <a:off x="777240" y="15206472"/>
+            <a:ext cx="28721303" cy="22311360"/>
           </a:xfrm>
           <a:prstGeom prst="roundRect">
             <a:avLst>
@@ -13533,7 +13459,7 @@
         </p:nvSpPr>
         <p:spPr>
           <a:xfrm>
-            <a:off x="777240" y="16962120"/>
+            <a:off x="777240" y="15389351"/>
             <a:ext cx="28721303" cy="731520"/>
           </a:xfrm>
           <a:prstGeom prst="rect">
@@ -13572,8 +13498,8 @@
         </p:nvSpPr>
         <p:spPr>
           <a:xfrm>
-            <a:off x="1234440" y="17876520"/>
-            <a:ext cx="7223760" cy="3611880"/>
+            <a:off x="1234440" y="16303751"/>
+            <a:ext cx="7223760" cy="3886200"/>
           </a:xfrm>
           <a:prstGeom prst="roundRect">
             <a:avLst>
@@ -13616,7 +13542,7 @@
         </p:nvSpPr>
         <p:spPr>
           <a:xfrm>
-            <a:off x="1508760" y="18150840"/>
+            <a:off x="1508760" y="16578072"/>
             <a:ext cx="868680" cy="868680"/>
           </a:xfrm>
           <a:prstGeom prst="ellipse">
@@ -13673,7 +13599,7 @@
         </p:nvSpPr>
         <p:spPr>
           <a:xfrm>
-            <a:off x="2560320" y="18223992"/>
+            <a:off x="2560320" y="16651223"/>
             <a:ext cx="5760720" cy="731520"/>
           </a:xfrm>
           <a:prstGeom prst="rect">
@@ -13712,8 +13638,8 @@
         </p:nvSpPr>
         <p:spPr>
           <a:xfrm>
-            <a:off x="1508760" y="19110960"/>
-            <a:ext cx="6766560" cy="2331720"/>
+            <a:off x="1508760" y="17538192"/>
+            <a:ext cx="6766560" cy="2606040"/>
           </a:xfrm>
           <a:prstGeom prst="rect">
             <a:avLst/>
@@ -13787,7 +13713,7 @@
         </p:nvSpPr>
         <p:spPr>
           <a:xfrm>
-            <a:off x="8686800" y="19316700"/>
+            <a:off x="8686800" y="17881092"/>
             <a:ext cx="914400" cy="731520"/>
           </a:xfrm>
           <a:prstGeom prst="rightArrow">
@@ -13831,8 +13757,8 @@
         </p:nvSpPr>
         <p:spPr>
           <a:xfrm>
-            <a:off x="1234440" y="21808440"/>
-            <a:ext cx="7223760" cy="3611880"/>
+            <a:off x="1234440" y="20509992"/>
+            <a:ext cx="7223760" cy="3886200"/>
           </a:xfrm>
           <a:prstGeom prst="roundRect">
             <a:avLst>
@@ -13875,7 +13801,7 @@
         </p:nvSpPr>
         <p:spPr>
           <a:xfrm>
-            <a:off x="1508760" y="22082760"/>
+            <a:off x="1508760" y="20784312"/>
             <a:ext cx="868680" cy="868680"/>
           </a:xfrm>
           <a:prstGeom prst="ellipse">
@@ -13932,7 +13858,7 @@
         </p:nvSpPr>
         <p:spPr>
           <a:xfrm>
-            <a:off x="2560320" y="22155912"/>
+            <a:off x="2560320" y="20857464"/>
             <a:ext cx="5760720" cy="731520"/>
           </a:xfrm>
           <a:prstGeom prst="rect">
@@ -13971,8 +13897,8 @@
         </p:nvSpPr>
         <p:spPr>
           <a:xfrm>
-            <a:off x="1508760" y="23042880"/>
-            <a:ext cx="6766560" cy="2331720"/>
+            <a:off x="1508760" y="21744432"/>
+            <a:ext cx="6766560" cy="2606040"/>
           </a:xfrm>
           <a:prstGeom prst="rect">
             <a:avLst/>
@@ -14064,7 +13990,7 @@
         </p:nvSpPr>
         <p:spPr>
           <a:xfrm>
-            <a:off x="8686800" y="23248620"/>
+            <a:off x="8686800" y="22087332"/>
             <a:ext cx="914400" cy="731520"/>
           </a:xfrm>
           <a:prstGeom prst="rightArrow">
@@ -14108,8 +14034,8 @@
         </p:nvSpPr>
         <p:spPr>
           <a:xfrm>
-            <a:off x="1234440" y="25740360"/>
-            <a:ext cx="7223760" cy="3611880"/>
+            <a:off x="1234440" y="24716231"/>
+            <a:ext cx="7223760" cy="3886200"/>
           </a:xfrm>
           <a:prstGeom prst="roundRect">
             <a:avLst>
@@ -14152,7 +14078,7 @@
         </p:nvSpPr>
         <p:spPr>
           <a:xfrm>
-            <a:off x="1508760" y="26014680"/>
+            <a:off x="1508760" y="24990552"/>
             <a:ext cx="868680" cy="868680"/>
           </a:xfrm>
           <a:prstGeom prst="ellipse">
@@ -14209,7 +14135,7 @@
         </p:nvSpPr>
         <p:spPr>
           <a:xfrm>
-            <a:off x="2560320" y="26087831"/>
+            <a:off x="2560320" y="25063703"/>
             <a:ext cx="5760720" cy="731520"/>
           </a:xfrm>
           <a:prstGeom prst="rect">
@@ -14248,8 +14174,8 @@
         </p:nvSpPr>
         <p:spPr>
           <a:xfrm>
-            <a:off x="1508760" y="26974800"/>
-            <a:ext cx="6766560" cy="2331720"/>
+            <a:off x="1508760" y="25950672"/>
+            <a:ext cx="6766560" cy="2606040"/>
           </a:xfrm>
           <a:prstGeom prst="rect">
             <a:avLst/>
@@ -14350,7 +14276,7 @@
         </p:nvSpPr>
         <p:spPr>
           <a:xfrm>
-            <a:off x="8686800" y="27180540"/>
+            <a:off x="8686800" y="26293572"/>
             <a:ext cx="914400" cy="731520"/>
           </a:xfrm>
           <a:prstGeom prst="rightArrow">
@@ -14394,8 +14320,8 @@
         </p:nvSpPr>
         <p:spPr>
           <a:xfrm>
-            <a:off x="1234440" y="29672280"/>
-            <a:ext cx="7223760" cy="3611880"/>
+            <a:off x="1234440" y="28922471"/>
+            <a:ext cx="7223760" cy="3886200"/>
           </a:xfrm>
           <a:prstGeom prst="roundRect">
             <a:avLst>
@@ -14438,7 +14364,7 @@
         </p:nvSpPr>
         <p:spPr>
           <a:xfrm>
-            <a:off x="1508760" y="29946600"/>
+            <a:off x="1508760" y="29196791"/>
             <a:ext cx="868680" cy="868680"/>
           </a:xfrm>
           <a:prstGeom prst="ellipse">
@@ -14495,7 +14421,7 @@
         </p:nvSpPr>
         <p:spPr>
           <a:xfrm>
-            <a:off x="2560320" y="30019752"/>
+            <a:off x="2560320" y="29269944"/>
             <a:ext cx="5760720" cy="731520"/>
           </a:xfrm>
           <a:prstGeom prst="rect">
@@ -14534,8 +14460,8 @@
         </p:nvSpPr>
         <p:spPr>
           <a:xfrm>
-            <a:off x="1508760" y="30906720"/>
-            <a:ext cx="6766560" cy="2331720"/>
+            <a:off x="1508760" y="30156911"/>
+            <a:ext cx="6766560" cy="2606040"/>
           </a:xfrm>
           <a:prstGeom prst="rect">
             <a:avLst/>
@@ -14627,7 +14553,7 @@
         </p:nvSpPr>
         <p:spPr>
           <a:xfrm>
-            <a:off x="8686800" y="31112460"/>
+            <a:off x="8686800" y="30499811"/>
             <a:ext cx="914400" cy="731520"/>
           </a:xfrm>
           <a:prstGeom prst="rightArrow">
@@ -14671,8 +14597,8 @@
         </p:nvSpPr>
         <p:spPr>
           <a:xfrm>
-            <a:off x="1234440" y="33604200"/>
-            <a:ext cx="7223760" cy="3611880"/>
+            <a:off x="1234440" y="33128711"/>
+            <a:ext cx="7223760" cy="3886200"/>
           </a:xfrm>
           <a:prstGeom prst="roundRect">
             <a:avLst>
@@ -14715,7 +14641,7 @@
         </p:nvSpPr>
         <p:spPr>
           <a:xfrm>
-            <a:off x="1508760" y="33878520"/>
+            <a:off x="1508760" y="33403031"/>
             <a:ext cx="868680" cy="868680"/>
           </a:xfrm>
           <a:prstGeom prst="ellipse">
@@ -14772,7 +14698,7 @@
         </p:nvSpPr>
         <p:spPr>
           <a:xfrm>
-            <a:off x="2560320" y="33951672"/>
+            <a:off x="2560320" y="33476184"/>
             <a:ext cx="5760720" cy="731520"/>
           </a:xfrm>
           <a:prstGeom prst="rect">
@@ -14811,8 +14737,8 @@
         </p:nvSpPr>
         <p:spPr>
           <a:xfrm>
-            <a:off x="1508760" y="34838640"/>
-            <a:ext cx="6766560" cy="2331720"/>
+            <a:off x="1508760" y="34363152"/>
+            <a:ext cx="6766560" cy="2606040"/>
           </a:xfrm>
           <a:prstGeom prst="rect">
             <a:avLst/>
@@ -14868,7 +14794,7 @@
         </p:nvSpPr>
         <p:spPr>
           <a:xfrm>
-            <a:off x="8686800" y="35044380"/>
+            <a:off x="8686800" y="34706052"/>
             <a:ext cx="914400" cy="731520"/>
           </a:xfrm>
           <a:prstGeom prst="rightArrow">
@@ -14920,8 +14846,8 @@
         </p:blipFill>
         <p:spPr>
           <a:xfrm>
-            <a:off x="9875520" y="17876520"/>
-            <a:ext cx="4735742" cy="3611880"/>
+            <a:off x="9875520" y="16303751"/>
+            <a:ext cx="5095419" cy="3886200"/>
           </a:xfrm>
           <a:prstGeom prst="rect">
             <a:avLst/>
@@ -14936,8 +14862,8 @@
         </p:nvSpPr>
         <p:spPr>
           <a:xfrm>
-            <a:off x="14977022" y="17876520"/>
-            <a:ext cx="14064321" cy="3611880"/>
+            <a:off x="15336699" y="16303751"/>
+            <a:ext cx="13704644" cy="3886200"/>
           </a:xfrm>
           <a:prstGeom prst="roundRect">
             <a:avLst>
@@ -15082,8 +15008,8 @@
         </p:blipFill>
         <p:spPr>
           <a:xfrm>
-            <a:off x="9875520" y="21808440"/>
-            <a:ext cx="4476026" cy="3611880"/>
+            <a:off x="9875520" y="20509992"/>
+            <a:ext cx="4815977" cy="3886200"/>
           </a:xfrm>
           <a:prstGeom prst="rect">
             <a:avLst/>
@@ -15098,8 +15024,8 @@
         </p:nvSpPr>
         <p:spPr>
           <a:xfrm>
-            <a:off x="14717306" y="21808440"/>
-            <a:ext cx="14324037" cy="3611880"/>
+            <a:off x="15057257" y="20509992"/>
+            <a:ext cx="13984086" cy="3886200"/>
           </a:xfrm>
           <a:prstGeom prst="roundRect">
             <a:avLst>
@@ -15269,8 +15195,8 @@
         </p:blipFill>
         <p:spPr>
           <a:xfrm>
-            <a:off x="9875520" y="25740360"/>
-            <a:ext cx="4831159" cy="3611880"/>
+            <a:off x="9875520" y="24716231"/>
+            <a:ext cx="5198083" cy="3886200"/>
           </a:xfrm>
           <a:prstGeom prst="rect">
             <a:avLst/>
@@ -15293,8 +15219,8 @@
         </p:blipFill>
         <p:spPr>
           <a:xfrm>
-            <a:off x="15026719" y="25740360"/>
-            <a:ext cx="4845407" cy="3611880"/>
+            <a:off x="15393643" y="24716231"/>
+            <a:ext cx="5213413" cy="3886200"/>
           </a:xfrm>
           <a:prstGeom prst="rect">
             <a:avLst/>
@@ -15317,8 +15243,8 @@
         </p:blipFill>
         <p:spPr>
           <a:xfrm>
-            <a:off x="20192167" y="25740360"/>
-            <a:ext cx="5965805" cy="3611880"/>
+            <a:off x="20927096" y="24716231"/>
+            <a:ext cx="6418904" cy="3886200"/>
           </a:xfrm>
           <a:prstGeom prst="rect">
             <a:avLst/>
@@ -15341,8 +15267,8 @@
         </p:blipFill>
         <p:spPr>
           <a:xfrm>
-            <a:off x="9875520" y="29672280"/>
-            <a:ext cx="5208275" cy="3611880"/>
+            <a:off x="9875520" y="28922471"/>
+            <a:ext cx="5603841" cy="3886200"/>
           </a:xfrm>
           <a:prstGeom prst="rect">
             <a:avLst/>
@@ -15357,8 +15283,8 @@
         </p:nvSpPr>
         <p:spPr>
           <a:xfrm>
-            <a:off x="15449555" y="29672280"/>
-            <a:ext cx="13591788" cy="3611880"/>
+            <a:off x="15845121" y="28922471"/>
+            <a:ext cx="13196222" cy="3886200"/>
           </a:xfrm>
           <a:prstGeom prst="roundRect">
             <a:avLst>
@@ -15467,8 +15393,8 @@
         </p:blipFill>
         <p:spPr>
           <a:xfrm>
-            <a:off x="9875520" y="33604200"/>
-            <a:ext cx="4986933" cy="3611880"/>
+            <a:off x="9875520" y="33128711"/>
+            <a:ext cx="5365688" cy="3886200"/>
           </a:xfrm>
           <a:prstGeom prst="rect">
             <a:avLst/>
@@ -15483,8 +15409,8 @@
         </p:nvSpPr>
         <p:spPr>
           <a:xfrm>
-            <a:off x="15228213" y="33604200"/>
-            <a:ext cx="13813130" cy="3611880"/>
+            <a:off x="15606968" y="33128711"/>
+            <a:ext cx="13434375" cy="3886200"/>
           </a:xfrm>
           <a:prstGeom prst="roundRect">
             <a:avLst>
@@ -15617,8 +15543,8 @@
         </p:nvSpPr>
         <p:spPr>
           <a:xfrm>
-            <a:off x="777240" y="38039040"/>
-            <a:ext cx="11521440" cy="4160519"/>
+            <a:off x="777240" y="37975032"/>
+            <a:ext cx="11521440" cy="4224527"/>
           </a:xfrm>
           <a:prstGeom prst="roundRect">
             <a:avLst>
@@ -15661,7 +15587,7 @@
         </p:nvSpPr>
         <p:spPr>
           <a:xfrm>
-            <a:off x="1097280" y="38267640"/>
+            <a:off x="1097280" y="38203632"/>
             <a:ext cx="10881360" cy="640080"/>
           </a:xfrm>
           <a:prstGeom prst="rect">
@@ -15700,8 +15626,8 @@
         </p:nvSpPr>
         <p:spPr>
           <a:xfrm>
-            <a:off x="1097280" y="38999160"/>
-            <a:ext cx="10881360" cy="3063239"/>
+            <a:off x="1097280" y="38935152"/>
+            <a:ext cx="10881360" cy="3127247"/>
           </a:xfrm>
           <a:prstGeom prst="rect">
             <a:avLst/>
@@ -15828,8 +15754,8 @@
         </p:nvSpPr>
         <p:spPr>
           <a:xfrm>
-            <a:off x="12710159" y="38039040"/>
-            <a:ext cx="16788384" cy="4160519"/>
+            <a:off x="12710159" y="37975032"/>
+            <a:ext cx="16788384" cy="4224527"/>
           </a:xfrm>
           <a:prstGeom prst="roundRect">
             <a:avLst>
@@ -15872,7 +15798,7 @@
         </p:nvSpPr>
         <p:spPr>
           <a:xfrm>
-            <a:off x="13030199" y="38267640"/>
+            <a:off x="13030199" y="38203632"/>
             <a:ext cx="16148304" cy="640080"/>
           </a:xfrm>
           <a:prstGeom prst="rect">
@@ -15911,8 +15837,8 @@
         </p:nvSpPr>
         <p:spPr>
           <a:xfrm>
-            <a:off x="13030199" y="38999160"/>
-            <a:ext cx="16148304" cy="2606039"/>
+            <a:off x="13030199" y="38935152"/>
+            <a:ext cx="16148304" cy="2670047"/>
           </a:xfrm>
           <a:prstGeom prst="rect">
             <a:avLst/>

</xml_diff>